<commit_message>
feat: finalize Submisi 2 pipeline (Model C LinearSVC+XGBoost), sync all documentation, update XAI justification, refresh final presentation PPTX, and lock MD5 da6faecbfb87d1f6a35b1f179902cde1
</commit_message>
<xml_diff>
--- a/docs/TIFIS_ID_PRESENTASI.pptx
+++ b/docs/TIFIS_ID_PRESENTASI.pptx
@@ -3454,7 +3454,7 @@
               </a:defRPr>
             </a:pPr>
             <a:r>
-              <a:t>📁 Berkas Submisi Resmi: submission_TIFIS_TIFIS.csv (MD5: ebd39c0c00675b8cae481251b6da23e5)</a:t>
+              <a:t>📁 Submisi 1: TIFIS TIFIS-01.csv (Skor 0.74417) | Submisi 2: TIFIS TIFIS-02.csv (MD5: da6faecbfb87d1f6a35b1f179902cde1)</a:t>
             </a:r>
           </a:p>
         </p:txBody>
@@ -4419,7 +4419,7 @@
               </a:defRPr>
             </a:pPr>
             <a:r>
-              <a:t>🌲 LightGBM (Bobot 40%): Menangkap interaksi non-linear registrar, usia domain, dan entropi</a:t>
+              <a:t>🚀 XGBoost / LightGBM (Bobot 40%): Menangkap interaksi non-linear registrar &amp; 56 fitur domain</a:t>
             </a:r>
           </a:p>
           <a:p>
@@ -4594,7 +4594,7 @@
               </a:defRPr>
             </a:pPr>
             <a:r>
-              <a:t>📈 Stratified 5-Fold CV Macro-F1: 0.6026 (Peningkatan +2.77% dibanding model baseline)</a:t>
+              <a:t>📈 Model Shootout OOF Macro-F1: 0.6044 (Model C LinearSVC + XGBoost Juara Mutlak)</a:t>
             </a:r>
           </a:p>
           <a:p>
@@ -4609,7 +4609,7 @@
               </a:defRPr>
             </a:pPr>
             <a:r>
-              <a:t>🛡️ Strict Domain Group-KFold: 0.5731 pada 100% unseen domains yang belum pernah dilatih</a:t>
+              <a:t>🏆 Bukti Empiris Submisi 1 di Server Panitia: Skor 0.74417 (True Positive Fakeshop Terkunci)</a:t>
             </a:r>
           </a:p>
           <a:p>

</xml_diff>